<commit_message>
Add slide + figure explaining the bimodal 10 GeV HCAL retained-fraction spread
Per-event f distributions at four selector windows for 10/50/200 GeV
pions: an f=0 population (no early-enough first deposit) plus prompt-rich
events near f=1 make the 68% spread peak mid-scan at 10 GeV; single-peaked
and monotonic at higher energies. Noted in PLAN.md 5.4.

Co-Authored-By: Claude Fable 5 <noreply@anthropic.com>
Claude-Session: https://claude.ai/code/session_01QfkMtYniJDh3tYADrTGibX
</commit_message>
<xml_diff>
--- a/timing_studies/slides/MAIA_timing_cuts_study.pptx
+++ b/timing_studies/slides/MAIA_timing_cuts_study.pptx
@@ -20,9 +20,10 @@
     <p:sldId id="268" r:id="rId14"/>
     <p:sldId id="269" r:id="rId15"/>
     <p:sldId id="270" r:id="rId16"/>
+    <p:sldId id="271" r:id="rId17"/>
   </p:sldIdLst>
   <p:notesMasterIdLst>
-    <p:notesMasterId r:id="rId17"/>
+    <p:notesMasterId r:id="rId18"/>
   </p:notesMasterIdLst>
   <p:sldSz cx="12192000" cy="6858000"/>
   <p:notesSz cx="6858000" cy="12192000"/>
@@ -1068,6 +1069,94 @@
             <a:fld id="{F7021451-1387-4CA6-816F-3879F97B5CBC}" type="slidenum">
               <a:rPr lang="en-US"/>
               <a:t>15</a:t>
+            </a:fld>
+            <a:endParaRPr lang="en-US"/>
+          </a:p>
+        </p:txBody>
+      </p:sp>
+    </p:spTree>
+    <p:extLst>
+      <p:ext uri="{BB962C8B-B14F-4D97-AF65-F5344CB8AC3E}">
+        <p14:creationId xmlns:p14="http://schemas.microsoft.com/office/powerpoint/2010/main" val="1024086991"/>
+      </p:ext>
+    </p:extLst>
+  </p:cSld>
+  <p:clrMapOvr>
+    <a:masterClrMapping/>
+  </p:clrMapOvr>
+</p:notes>
+</file>
+
+<file path=ppt/notesSlides/notesSlide16.xml><?xml version="1.0" encoding="utf-8"?>
+<p:notes xmlns:a="http://schemas.openxmlformats.org/drawingml/2006/main" xmlns:r="http://schemas.openxmlformats.org/officeDocument/2006/relationships" xmlns:p="http://schemas.openxmlformats.org/presentationml/2006/main">
+  <p:cSld>
+    <p:spTree>
+      <p:nvGrpSpPr>
+        <p:cNvPr id="1" name=""/>
+        <p:cNvGrpSpPr/>
+        <p:nvPr/>
+      </p:nvGrpSpPr>
+      <p:grpSpPr>
+        <a:xfrm>
+          <a:off x="0" y="0"/>
+          <a:ext cx="0" cy="0"/>
+          <a:chOff x="0" y="0"/>
+          <a:chExt cx="0" cy="0"/>
+        </a:xfrm>
+      </p:grpSpPr>
+      <p:sp>
+        <p:nvSpPr>
+          <p:cNvPr id="2" name="Slide Image Placeholder 1"/>
+          <p:cNvSpPr>
+            <a:spLocks noGrp="1" noRot="1" noChangeAspect="1"/>
+          </p:cNvSpPr>
+          <p:nvPr>
+            <p:ph type="sldImg"/>
+          </p:nvPr>
+        </p:nvSpPr>
+        <p:spPr/>
+      </p:sp>
+      <p:sp>
+        <p:nvSpPr>
+          <p:cNvPr id="3" name="Notes Placeholder 2"/>
+          <p:cNvSpPr>
+            <a:spLocks noGrp="1"/>
+          </p:cNvSpPr>
+          <p:nvPr>
+            <p:ph type="body" idx="1"/>
+          </p:nvPr>
+        </p:nvSpPr>
+        <p:spPr/>
+        <p:txBody>
+          <a:bodyPr/>
+          <a:lstStyle/>
+          <a:p>
+            <a:r>
+              <a:rPr lang="en-US" dirty="0"/>
+              <a:t/>
+            </a:r>
+            <a:endParaRPr lang="en-US" dirty="0"/>
+          </a:p>
+        </p:txBody>
+      </p:sp>
+      <p:sp>
+        <p:nvSpPr>
+          <p:cNvPr id="4" name="Slide Number Placeholder 3"/>
+          <p:cNvSpPr>
+            <a:spLocks noGrp="1"/>
+          </p:cNvSpPr>
+          <p:nvPr>
+            <p:ph type="sldNum" sz="quarter" idx="10"/>
+          </p:nvPr>
+        </p:nvSpPr>
+        <p:spPr/>
+        <p:txBody>
+          <a:bodyPr/>
+          <a:lstStyle/>
+          <a:p>
+            <a:fld id="{F7021451-1387-4CA6-816F-3879F97B5CBC}" type="slidenum">
+              <a:rPr lang="en-US"/>
+              <a:t>16</a:t>
             </a:fld>
             <a:endParaRPr lang="en-US"/>
           </a:p>
@@ -10699,6 +10788,337 @@
 <file path=ppt/slides/slide15.xml><?xml version="1.0" encoding="utf-8"?>
 <p:sld xmlns:a="http://schemas.openxmlformats.org/drawingml/2006/main" xmlns:r="http://schemas.openxmlformats.org/officeDocument/2006/relationships" xmlns:p="http://schemas.openxmlformats.org/presentationml/2006/main">
   <p:cSld name="Slide 15">
+    <p:spTree>
+      <p:nvGrpSpPr>
+        <p:cNvPr id="1" name=""/>
+        <p:cNvGrpSpPr/>
+        <p:nvPr/>
+      </p:nvGrpSpPr>
+      <p:grpSpPr>
+        <a:xfrm>
+          <a:off x="0" y="0"/>
+          <a:ext cx="0" cy="0"/>
+          <a:chOff x="0" y="0"/>
+          <a:chExt cx="0" cy="0"/>
+        </a:xfrm>
+      </p:grpSpPr>
+      <p:sp>
+        <p:nvSpPr>
+          <p:cNvPr id="2" name="Text 0"/>
+          <p:cNvSpPr/>
+          <p:nvPr/>
+        </p:nvSpPr>
+        <p:spPr>
+          <a:xfrm>
+            <a:off x="548640" y="292608"/>
+            <a:ext cx="11091672" cy="566928"/>
+          </a:xfrm>
+          <a:prstGeom prst="rect">
+            <a:avLst/>
+          </a:prstGeom>
+          <a:noFill/>
+          <a:ln/>
+        </p:spPr>
+        <p:txBody>
+          <a:bodyPr wrap="square" lIns="0" tIns="0" rIns="0" bIns="0" rtlCol="0" anchor="ctr"/>
+          <a:lstStyle/>
+          <a:p>
+            <a:pPr indent="0" marL="0">
+              <a:buNone/>
+            </a:pPr>
+            <a:r>
+              <a:rPr lang="en-US" sz="3000" b="1" dirty="0">
+                <a:solidFill>
+                  <a:srgbClr val="1E2761"/>
+                </a:solidFill>
+                <a:latin typeface="Calibri" pitchFamily="34" charset="0"/>
+                <a:ea typeface="Calibri" pitchFamily="34" charset="-122"/>
+                <a:cs typeface="Calibri" pitchFamily="34" charset="-120"/>
+              </a:rPr>
+              <a:t>The 10 GeV HCAL spread bump, explained</a:t>
+            </a:r>
+            <a:endParaRPr lang="en-US" sz="3000" dirty="0"/>
+          </a:p>
+        </p:txBody>
+      </p:sp>
+      <p:sp>
+        <p:nvSpPr>
+          <p:cNvPr id="3" name="Text 1"/>
+          <p:cNvSpPr/>
+          <p:nvPr/>
+        </p:nvSpPr>
+        <p:spPr>
+          <a:xfrm>
+            <a:off x="548640" y="841248"/>
+            <a:ext cx="11091672" cy="310896"/>
+          </a:xfrm>
+          <a:prstGeom prst="rect">
+            <a:avLst/>
+          </a:prstGeom>
+          <a:noFill/>
+          <a:ln/>
+        </p:spPr>
+        <p:txBody>
+          <a:bodyPr wrap="square" lIns="0" tIns="0" rIns="0" bIns="0" rtlCol="0" anchor="ctr"/>
+          <a:lstStyle/>
+          <a:p>
+            <a:pPr indent="0" marL="0">
+              <a:buNone/>
+            </a:pPr>
+            <a:r>
+              <a:rPr lang="en-US" sz="1300" dirty="0">
+                <a:solidFill>
+                  <a:srgbClr val="5A6472"/>
+                </a:solidFill>
+                <a:latin typeface="Calibri" pitchFamily="34" charset="0"/>
+                <a:ea typeface="Calibri" pitchFamily="34" charset="-122"/>
+                <a:cs typeface="Calibri" pitchFamily="34" charset="-120"/>
+              </a:rPr>
+              <a:t>The 68% band on the previous slide is a percentile of a distribution that is far from Gaussian at low energy — here are the distributions themselves</a:t>
+            </a:r>
+            <a:endParaRPr lang="en-US" sz="1300" dirty="0"/>
+          </a:p>
+        </p:txBody>
+      </p:sp>
+      <p:sp>
+        <p:nvSpPr>
+          <p:cNvPr id="4" name="Shape 2"/>
+          <p:cNvSpPr/>
+          <p:nvPr/>
+        </p:nvSpPr>
+        <p:spPr>
+          <a:xfrm>
+            <a:off x="548640" y="1234440"/>
+            <a:ext cx="11091672" cy="548640"/>
+          </a:xfrm>
+          <a:prstGeom prst="roundRect">
+            <a:avLst>
+              <a:gd name="adj" fmla="val 10000"/>
+            </a:avLst>
+          </a:prstGeom>
+          <a:solidFill>
+            <a:srgbClr val="EAF1FD"/>
+          </a:solidFill>
+          <a:ln w="12700">
+            <a:solidFill>
+              <a:srgbClr val="CADCFC"/>
+            </a:solidFill>
+            <a:prstDash val="solid"/>
+          </a:ln>
+        </p:spPr>
+      </p:sp>
+      <p:sp>
+        <p:nvSpPr>
+          <p:cNvPr id="5" name="Text 3"/>
+          <p:cNvSpPr/>
+          <p:nvPr/>
+        </p:nvSpPr>
+        <p:spPr>
+          <a:xfrm>
+            <a:off x="685800" y="1234440"/>
+            <a:ext cx="10817352" cy="548640"/>
+          </a:xfrm>
+          <a:prstGeom prst="rect">
+            <a:avLst/>
+          </a:prstGeom>
+          <a:noFill/>
+          <a:ln/>
+        </p:spPr>
+        <p:txBody>
+          <a:bodyPr wrap="square" lIns="0" tIns="0" rIns="0" bIns="0" rtlCol="0" anchor="ctr"/>
+          <a:lstStyle/>
+          <a:p>
+            <a:pPr indent="0" marL="0">
+              <a:buNone/>
+            </a:pPr>
+            <a:r>
+              <a:rPr lang="en-US" sz="1150" b="1" dirty="0">
+                <a:solidFill>
+                  <a:srgbClr val="1E2761"/>
+                </a:solidFill>
+                <a:latin typeface="Calibri" pitchFamily="34" charset="0"/>
+                <a:ea typeface="Calibri" pitchFamily="34" charset="-122"/>
+                <a:cs typeface="Calibri" pitchFamily="34" charset="-120"/>
+              </a:rPr>
+              <a:t>Cut configuration:  </a:t>
+            </a:r>
+            <a:pPr indent="0" marL="0">
+              <a:buNone/>
+            </a:pPr>
+            <a:r>
+              <a:rPr lang="en-US" sz="1150" dirty="0">
+                <a:solidFill>
+                  <a:srgbClr val="222222"/>
+                </a:solidFill>
+                <a:latin typeface="Calibri" pitchFamily="34" charset="0"/>
+                <a:ea typeface="Calibri" pitchFamily="34" charset="-122"/>
+                <a:cs typeface="Calibri" pitchFamily="34" charset="-120"/>
+              </a:rPr>
+              <a:t>HCAL barrel, π⁻; digi window FIXED at default (−0.5, +10) ns; selector windows in the legends. f = per-event E(window) / E(no timing cuts) — the same quantity whose median and 68% band appear on the previous slide.</a:t>
+            </a:r>
+            <a:endParaRPr lang="en-US" sz="1150" dirty="0"/>
+          </a:p>
+        </p:txBody>
+      </p:sp>
+      <p:pic>
+        <p:nvPicPr>
+          <p:cNvPr id="6" name="Image 0" descr="../plots/hcal_pions/fraction_dist_HcalBarrel.png">    </p:cNvPr>
+          <p:cNvPicPr>
+            <a:picLocks noChangeAspect="1"/>
+          </p:cNvPicPr>
+          <p:nvPr/>
+        </p:nvPicPr>
+        <p:blipFill>
+          <a:blip r:embed="rId1"/>
+          <a:stretch>
+            <a:fillRect/>
+          </a:stretch>
+        </p:blipFill>
+        <p:spPr>
+          <a:xfrm>
+            <a:off x="868680" y="1901952"/>
+            <a:ext cx="10469880" cy="3145536"/>
+          </a:xfrm>
+          <a:prstGeom prst="rect">
+            <a:avLst/>
+          </a:prstGeom>
+        </p:spPr>
+      </p:pic>
+      <p:sp>
+        <p:nvSpPr>
+          <p:cNvPr id="7" name="Text 4"/>
+          <p:cNvSpPr/>
+          <p:nvPr/>
+        </p:nvSpPr>
+        <p:spPr>
+          <a:xfrm>
+            <a:off x="548640" y="5138928"/>
+            <a:ext cx="11091672" cy="1463040"/>
+          </a:xfrm>
+          <a:prstGeom prst="rect">
+            <a:avLst/>
+          </a:prstGeom>
+          <a:noFill/>
+          <a:ln/>
+        </p:spPr>
+        <p:txBody>
+          <a:bodyPr wrap="square" lIns="0" tIns="0" rIns="0" bIns="0" rtlCol="0" anchor="t"/>
+          <a:lstStyle/>
+          <a:p>
+            <a:pPr marL="152400" indent="-152400">
+              <a:spcAft>
+                <a:spcPts val="800"/>
+              </a:spcAft>
+              <a:buSzPct val="100000"/>
+              <a:buChar char="•"/>
+            </a:pPr>
+            <a:r>
+              <a:rPr lang="en-US" sz="1050" b="1" dirty="0">
+                <a:solidFill>
+                  <a:srgbClr val="222222"/>
+                </a:solidFill>
+                <a:latin typeface="Calibri" pitchFamily="34" charset="0"/>
+                <a:ea typeface="Calibri" pitchFamily="34" charset="-122"/>
+                <a:cs typeface="Calibri" pitchFamily="34" charset="-120"/>
+              </a:rPr>
+              <a:t>10 GeV: a distinct population retains f = 0 exactly — 17 events at the current ±0.3 ns, still 9 at ±2 ns: no HCAL cell has an early-enough FIRST deposit (the HCAL piece is small — median ~2 GeV, ~15 cells — late and neutron-dominated). The 16th percentile sits at 0 up to w = 0.3 ns.</a:t>
+            </a:r>
+            <a:endParaRPr lang="en-US" sz="1050" dirty="0"/>
+          </a:p>
+          <a:p>
+            <a:pPr marL="152400" indent="-152400">
+              <a:spcAft>
+                <a:spcPts val="800"/>
+              </a:spcAft>
+              <a:buSzPct val="100000"/>
+              <a:buChar char="•"/>
+            </a:pPr>
+            <a:r>
+              <a:rPr lang="en-US" sz="1050" dirty="0">
+                <a:solidFill>
+                  <a:srgbClr val="222222"/>
+                </a:solidFill>
+                <a:latin typeface="Calibri" pitchFamily="34" charset="0"/>
+                <a:ea typeface="Calibri" pitchFamily="34" charset="-122"/>
+                <a:cs typeface="Calibri" pitchFamily="34" charset="-120"/>
+              </a:rPr>
+              <a:t>Opening the window pulls prompt-rich events to f ≈ 1 while late-dominated events stay near 0: the distribution stretches across [0, 1], so the 68% spread PEAKS (~0.40 at w ≈ 0.4–0.75 ns) where the median crosses mid-range — a p(1−p)-type maximum — then collapses as everything converges to f ≈ 1. The rise-then-fall of the blue curve is expected, not a glitch.</a:t>
+            </a:r>
+            <a:endParaRPr lang="en-US" sz="1050" dirty="0"/>
+          </a:p>
+          <a:p>
+            <a:pPr marL="152400" indent="-152400">
+              <a:spcAft>
+                <a:spcPts val="800"/>
+              </a:spcAft>
+              <a:buSzPct val="100000"/>
+              <a:buChar char="•"/>
+            </a:pPr>
+            <a:r>
+              <a:rPr lang="en-US" sz="1050" dirty="0">
+                <a:solidFill>
+                  <a:srgbClr val="222222"/>
+                </a:solidFill>
+                <a:latin typeface="Calibri" pitchFamily="34" charset="0"/>
+                <a:ea typeface="Calibri" pitchFamily="34" charset="-122"/>
+                <a:cs typeface="Calibri" pitchFamily="34" charset="-120"/>
+              </a:rPr>
+              <a:t>50 / 200 GeV: showers average over many more cells and sub-showers — a single peak that narrows and moves right, no f = 0 spike, monotonic spread. At 10 GeV and ±0.3 ns the HCAL flips between seeing the shower and seeing nothing, event by event — not a smeared measurement.</a:t>
+            </a:r>
+            <a:endParaRPr lang="en-US" sz="1050" dirty="0"/>
+          </a:p>
+        </p:txBody>
+      </p:sp>
+      <p:sp>
+        <p:nvSpPr>
+          <p:cNvPr id="8" name="Text 5"/>
+          <p:cNvSpPr/>
+          <p:nvPr/>
+        </p:nvSpPr>
+        <p:spPr>
+          <a:xfrm>
+            <a:off x="8348472" y="6510528"/>
+            <a:ext cx="3566160" cy="274320"/>
+          </a:xfrm>
+          <a:prstGeom prst="rect">
+            <a:avLst/>
+          </a:prstGeom>
+          <a:noFill/>
+          <a:ln/>
+        </p:spPr>
+        <p:txBody>
+          <a:bodyPr wrap="square" lIns="0" tIns="0" rIns="0" bIns="0" rtlCol="0" anchor="ctr"/>
+          <a:lstStyle/>
+          <a:p>
+            <a:pPr algn="r" indent="0" marL="0">
+              <a:buNone/>
+            </a:pPr>
+            <a:r>
+              <a:rPr lang="en-US" sz="900" dirty="0">
+                <a:solidFill>
+                  <a:srgbClr val="5A6472"/>
+                </a:solidFill>
+                <a:latin typeface="Calibri" pitchFamily="34" charset="0"/>
+                <a:ea typeface="Calibri" pitchFamily="34" charset="-122"/>
+                <a:cs typeface="Calibri" pitchFamily="34" charset="-120"/>
+              </a:rPr>
+              <a:t>MAIA calorimeter timing-cut study  ·  15</a:t>
+            </a:r>
+            <a:endParaRPr lang="en-US" sz="900" dirty="0"/>
+          </a:p>
+        </p:txBody>
+      </p:sp>
+    </p:spTree>
+  </p:cSld>
+  <p:clrMapOvr>
+    <a:masterClrMapping/>
+  </p:clrMapOvr>
+</p:sld>
+</file>
+
+<file path=ppt/slides/slide16.xml><?xml version="1.0" encoding="utf-8"?>
+<p:sld xmlns:a="http://schemas.openxmlformats.org/drawingml/2006/main" xmlns:r="http://schemas.openxmlformats.org/officeDocument/2006/relationships" xmlns:p="http://schemas.openxmlformats.org/presentationml/2006/main">
+  <p:cSld name="Slide 16">
     <p:bg>
       <p:bgPr>
         <a:solidFill>

</xml_diff>